<commit_message>
Replace deck speaker notes with verbatim 10-minute script
1,430 words across ten slides, spoken register, every concept defined
on first appearance, chart walk-throughs, transitions between slides.
Slides and images byte-identical; notes only.

Co-Authored-By: Claude Fable 5 <noreply@anthropic.com>
</commit_message>
<xml_diff>
--- a/briefings/phase3-findings-10min.pptx
+++ b/briefings/phase3-findings-10min.pptx
@@ -511,7 +511,7 @@
           <a:p>
             <a:r>
               <a:rPr lang="en-US" dirty="0"/>
-              <a:t>Open with the question on the screen and give people a beat to answer it in their heads. This is a standard laboratory economics question, the kind run on human subjects since the 1970s to measure how people handle risk. We asked AI models thousands of these, then traced the answers back through each model's training history. The headline, which I will spend the next nine minutes earning: almost everything about how these models handle money appears at one specific training step, and it is the first and simplest one.</a:t>
+              <a:t>Take a second and answer that one yourself. A sure eighty-six dollars, or a forty-three percent shot at two hundred and ten. The gamble pays more on average, about ninety dollars, and leaves you with nothing more than half the time. Which one you pick says something about how you handle risk, and economists have been asking people questions like this since the nineteen seventies. We asked AI models thousands of them, then traced the answers back through each model's training history. Here is where I am going. Almost everything about how these models handle money arrives at one training step, and it is the first and simplest one. Let me start with why anyone should care.</a:t>
             </a:r>
             <a:endParaRPr lang="en-US" dirty="0"/>
           </a:p>
@@ -599,7 +599,7 @@
           <a:p>
             <a:r>
               <a:rPr lang="en-US" dirty="0"/>
-              <a:t>Three follow-ups, and the first matters most because it tests the ceiling this phase ran into. Let the model reason before it answers, and we find out whether the arithmetic failure was inability or format. Second, make the payoffs real by denominating them in a computation budget the model spends, which is the piece that makes the induced-value method work on human subjects. Third, the same instrument measures social preferences, so the fall project asks whether models cooperate more readily with counterparts they take to be their own kind. Happy to take questions.</a:t>
+              <a:t>Three follow-ups for the fall. The first matters most; it tests this phase's ceiling. Every answer here had to be one letter, produced immediately. Give it room to work the arithmetic out first, and we learn whether it cannot compute or simply does not. Second, make the stakes real. Nothing was at stake here. Denominating payoffs in computing time the model actually spends turns a hypothetical into a real incentive, which is what makes the method work on people. Third, the same machinery measures social preferences, so we ask whether a model cooperates more with a counterpart it takes for its own kind. The money personality arrives at one training step, and that is where to look. Thank you.</a:t>
             </a:r>
             <a:endParaRPr lang="en-US" dirty="0"/>
           </a:p>
@@ -687,7 +687,7 @@
           <a:p>
             <a:r>
               <a:rPr lang="en-US" dirty="0"/>
-              <a:t>Three reasons this is worth an afternoon. First, these systems are already inside economic decisions, and one that quietly prefers certainty to expected value will bias every recommendation it makes. Second, we do not have to ask a model what it values. Economics has a mature toolkit for reading preferences out of choices, and it works on a model exactly as it works on a person. Third, and this is the gap Phase 3 fills, everyone tests the finished product. Nobody opens the box and asks which manufacturing step put the behavior there.</a:t>
+              <a:t>Why check what an AI prefers? Three reasons. These systems already sit inside real money decisions. They draft budgets, screen loan files, price contracts, and advise people on retirement accounts. Every one is a choice under uncertainty, and a system that quietly prefers a sure thing to a better bet tilts every recommendation. Second, we do not have to ask a model what it values. Economists spent fifty years reading preferences out of what people choose rather than what they say about themselves, and that method transfers to a model unchanged. Third, and this is my gap, everybody tests the finished chatbot and stops. Nobody asks which manufacturing step put the behavior there. Here is how we opened the box.</a:t>
             </a:r>
             <a:endParaRPr lang="en-US" dirty="0"/>
           </a:p>
@@ -775,7 +775,7 @@
           <a:p>
             <a:r>
               <a:rPr lang="en-US" dirty="0"/>
-              <a:t>The instrument is a grid of 1,680 questions: forty gambles, each rewritten five ways, each shown in both orders, each posed once as a gain and once as a loss. Because the wording is fixed and only one feature moves at a time, any change in behavior traces to that one feature. The efficiency trick is that we do not sample answers. We read the model's answer directly from its internal probabilities, so a single pass gives the exact answer instead of an estimate from twenty-five repeated tries. Eighty of the questions are pure free money, and those turn out to matter more than anything else on this slide.</a:t>
+              <a:t>The instrument is a grid of one thousand six hundred and eighty questions. Forty gambles, each rewritten five ways, each shown in both orders, each posed once as a gain and once as a loss. Only one feature moves at a time, so any change in behavior traces to that feature. Seventeen runs, four families, twenty-eight thousand five hundred and sixty answers. We never make the model type a reply. The model assigns odds to every possible next word, so we look at the odds it puts on A versus B, and one pass gives the exact answer. Eighty of these questions are free money: a sure fifty against a sure seventy. Those eighty matter more than anything else here.</a:t>
             </a:r>
             <a:endParaRPr lang="en-US" dirty="0"/>
           </a:p>
@@ -863,7 +863,7 @@
           <a:p>
             <a:r>
               <a:rPr lang="en-US" dirty="0"/>
-              <a:t>Before a model is trained to behave like an assistant, it is a text-continuation engine. It will answer A or B with total confidence and no hesitation. Offer it a sure fifty dollars against a sure seventy and it takes the seventy about as often as a coin flip: 55.5 percent for OLMo, 62.3 for Llama, 63.9 for Qwen. That is the reframe the whole project turns on. A base model does not have strange preferences, it has no usable preferences at all, and any number fitted to its choices describes randomness rather than taste. So whatever economic behavior we measure later was installed by training, not inherited from the internet.</a:t>
+              <a:t>Here is the free money result, and this is where the talk turns. Before a model is trained to act like an assistant it is a base model, which means it has read a huge chunk of the internet and nothing else. It answers A or B with total confidence. Look at the three grey bars. The dotted red line down the middle is a coin flip. Offer these base models a sure fifty against a sure seventy, no gambling involved, and OLMo takes the seventy fifty-five and a half percent of the time. Llama, sixty-two point three. Qwen, sixty-three point nine. Just over half the time. The purple bar on top is Claude Haiku, a finished assistant, at a hundred percent. Somebody always asks whether the answers are just random. This check settles it. A base model does not have strange preferences. It has no usable preferences at all. So whatever we measure later was installed by training rather than inherited from the internet. Installed when?</a:t>
             </a:r>
             <a:endParaRPr lang="en-US" dirty="0"/>
           </a:p>
@@ -951,7 +951,7 @@
           <a:p>
             <a:r>
               <a:rPr lang="en-US" dirty="0"/>
-              <a:t>This is the finding. OLMo-2 is the only family that publishes a snapshot after each stage of training, so we asked the same questions at four points in one model's life. Almost everything moves at the first step. Free-money accuracy climbs from 55.5 to 75.6 percent, and sensitivity to how a bet is worded more than doubles. The two later stages, the ones built on comparisons of human preferences, tighten accuracy on the easy questions and leave the economic behavior where fine-tuning put it. That is a surprise, because human feedback enters at those later stages, and they are the ones people blame when a model shows a human-like bias. Here the bias is already in place before that stage begins.</a:t>
+              <a:t>This slide answers it, and it is the finding. OLMo-2 is the one family that publishes a snapshot after every training step, so we asked identical questions at four points in one model's life. Along the bottom is that life story: pre-trained base, after supervised fine-tuning, after preference training, finished assistant. Supervised fine-tuning is the first step where humans show the model examples of being a helpful assistant. Look at the purple line, free money accuracy. It jumps from fifty-five and a half to seventy-five point six at that first step, then only crawls to eighty-eight point two and eighty-nine point six. The grey line below is extra gambling when a bet gets called a loss: nine point nine, twenty-four point three, thirty-one point eight, thirty-four point nine. Same shape. The whole personality appears inside that shaded band on the left. Human feedback enters at the later stages, and those are the ones everyone blames. Why does the step matter? That is where you would audit. One more wrinkle first.</a:t>
             </a:r>
             <a:endParaRPr lang="en-US" dirty="0"/>
           </a:p>
@@ -1039,7 +1039,7 @@
           <a:p>
             <a:r>
               <a:rPr lang="en-US" dirty="0"/>
-              <a:t>We ran a control that turned into a finding. Every finished assistant was asked the same questions two ways: as a chat message, and as a raw fill-in-the-blank completion. Qwen is a sensible economic subject in chat and collapses into near-total refusal to gamble in the other format. OLMo does exactly the reverse. Llama is steady in both. So a study comparing two models under one fixed format may be comparing an engaged subject against one that has checked out. The fix is cheap: before you analyze anything, confirm the model reliably picks seventy dollars over fifty. If it does not, the rest of its answers are not preferences.</a:t>
+              <a:t>We ran this next one as a control and it turned into a finding. Every finished assistant got the same questions two standard ways: as a chat message, the way you would type to a chatbot, and as a raw fill-in-the-blank where the model just continues text. Each row is one model, left dot fill-in, right dot chat. Qwen sits at sixty-eight fill-in and ninety-two point seven in chat. Chat wakes it up. OLMo does the reverse, eighty-nine point six as a fill-in and down to sixty-three point six in chat. Chat puts it to sleep. Llama is the steady one, seventy-eight point two and eighty point four. Same weights, same questions, two very different subjects. So a study comparing two models under one fixed format may be comparing an engaged subject against one that checked out. The fix is nearly free: before analyzing anything, confirm the model reliably picks seventy over fifty. Now to the bias people actually worry about.</a:t>
             </a:r>
             <a:endParaRPr lang="en-US" dirty="0"/>
           </a:p>
@@ -1127,7 +1127,7 @@
           <a:p>
             <a:r>
               <a:rPr lang="en-US" dirty="0"/>
-              <a:t>In Phase 2 we found that Claude Haiku becomes much more cautious when the downside of a bet is called a loss, which runs against the textbook prospect-theory direction. Every open model here does something different. Qwen becomes dramatically more willing to gamble, by 62.6 points. OLMo moves 34.9 points the same way. Llama hardly notices. The bets are arithmetically identical. The only thing that changes is the wording. Four systems, four responses. Anyone who reports a framing bias from one model and calls it a fact about language models is reporting a fact about that model's training recipe.</a:t>
+              <a:t>This chart is about wording. Take a bet and describe the downside as a loss instead of a smaller gain. The arithmetic is identical. Nothing about the money changes. Up means the model gambles more under the loss wording, down means less, and the flat line across the middle means no reaction. In an earlier phase we found Claude Haiku goes down, minus thirty point two, becoming noticeably more cautious. Every open model does something else. Qwen goes up sixty-two point six, nearly doubling its gambling on the very same bet. OLMo, up thirty-four point nine. Llama hardly notices at plus three point four, and it even flips direction depending on the format. Four systems, four reactions to one change in wording. My own instinct was that a bias this famous would be universal. It clearly is not. So anyone reporting a framing bias from one model and calling it a fact about language models is describing that model's training recipe. Can you just tell it to stop?</a:t>
             </a:r>
             <a:endParaRPr lang="en-US" dirty="0"/>
           </a:p>
@@ -1215,7 +1215,7 @@
           <a:p>
             <a:r>
               <a:rPr lang="en-US" dirty="0"/>
-              <a:t>Phil Armour, our reviewer, pointed at a standard move in experimental economics. Rather than guess what a subject wants, you tell the subject what to want and check whether it complies. We instructed the models in plain language: multiply the payoff by the probability and take the larger number. The bars show what happened. Compliance never rises above about 55 percent at any training stage, close to a coin flip. The black line is the same instruction on questions where following it needs no arithmetic at all, and there compliance reaches 100 percent. Asked for a harder rule involving a square root, one model's compliance fell to 12 percent with a legible error: it compared the transformed payoffs and dropped the probability entirely. These models are not refusing. They cannot run the arithmetic in a format that demands an immediate one-letter answer.</a:t>
+              <a:t>Our reviewer, Phil Armour, pointed at a standard move in experimental economics. Rather than guess what a subject wants, you tell the subject what to want and check whether they comply. So we instructed the models in plain English: multiply the payoff by the probability and take the bigger number. The paired bars show compliance before the instruction in grey and after it in purple, at each model and training stage. Fifty-two to fifty-four. Fifty-two to fifty-four. Forty-nine to fifty-two. Forty-seven to fifty-three. Forty-five to fifty-two. The dotted red line is a coin flip, and the instruction barely lifts anything off it. Now the black line along the top. That is the same instruction on questions where following it takes no arithmetic, and there compliance runs eighty-nine, seventy-five, ninety-four, then a hundred percent twice. So the models are not refusing us. They cannot do the arithmetic when the format demands an immediate one-letter answer. That is the honest caveat on everything before it. Let me pull it together.</a:t>
             </a:r>
             <a:endParaRPr lang="en-US" dirty="0"/>
           </a:p>
@@ -1303,7 +1303,7 @@
           <a:p>
             <a:r>
               <a:rPr lang="en-US" dirty="0"/>
-              <a:t>Four takeaways. The framing bias belongs to a training recipe rather than to AI as a technology, so a result measured on one model does not transfer to another by assumption. If the behavior is installed at supervised fine-tuning, the supervised data and the checkpoint right after it are the place to inspect and correct it, and that is not where the attention currently goes. Any evaluation of an AI's economic behavior needs an engagement check reported alongside the headline, for the same reason a survey reports its response rate. And you cannot instruct your way out of a trained disposition, at least not in this format.</a:t>
+              <a:t>Four takeaways, in the order they would change what somebody does Monday. One, the framing bias belongs to a training recipe rather than to AI as a technology, so a vulnerability documented on one model tells a procurement officer nothing reliable about the model being deployed. Two, look earlier than people do. If the behavior is installed at supervised fine-tuning, that data and the checkpoint right after it are where you inspect it, and that is not where attention goes. Three, check that the subject is awake, the way a survey reports its response rate. Four, instructions do not override training. Telling a model to maximize expected value moved it about three points. Here is where I take it next.</a:t>
             </a:r>
             <a:endParaRPr lang="en-US" dirty="0"/>
           </a:p>

</xml_diff>